<commit_message>
Add company logo and English wordmark to all four decks
Extracts the logo from the original IR deck and places it top-left
with the DYNAMIC INDUSTRY wordmark on every slide of the Korean and
English elevator decks and both one-page dashboards. Generator
scripts updated accordingly (logo.png added alongside them).

Co-Authored-By: Claude Fable 5 <noreply@anthropic.com>
Claude-Session: https://claude.ai/code/session_01NdSgsQRKAREDfNU5SmPuMT
</commit_message>
<xml_diff>
--- a/Dynamic_Industry_Elevator_Deck.pptx
+++ b/Dynamic_Industry_Elevator_Deck.pptx
@@ -1681,15 +1681,39 @@
           <a:ln/>
         </p:spPr>
       </p:sp>
-      <p:sp>
-        <p:nvSpPr>
-          <p:cNvPr id="6" name="Text 4"/>
-          <p:cNvSpPr/>
-          <p:nvPr/>
-        </p:nvSpPr>
-        <p:spPr>
-          <a:xfrm>
-            <a:off x="777240" y="685800"/>
+      <p:pic>
+        <p:nvPicPr>
+          <p:cNvPr id="6" name="Image 0" descr="preencoded.png">    </p:cNvPr>
+          <p:cNvPicPr>
+            <a:picLocks noChangeAspect="1"/>
+          </p:cNvPicPr>
+          <p:nvPr/>
+        </p:nvPicPr>
+        <p:blipFill>
+          <a:blip r:embed="rId1"/>
+          <a:stretch>
+            <a:fillRect/>
+          </a:stretch>
+        </p:blipFill>
+        <p:spPr>
+          <a:xfrm>
+            <a:off x="777240" y="676656"/>
+            <a:ext cx="713232" cy="640080"/>
+          </a:xfrm>
+          <a:prstGeom prst="rect">
+            <a:avLst/>
+          </a:prstGeom>
+        </p:spPr>
+      </p:pic>
+      <p:sp>
+        <p:nvSpPr>
+          <p:cNvPr id="7" name="Text 4"/>
+          <p:cNvSpPr/>
+          <p:nvPr/>
+        </p:nvSpPr>
+        <p:spPr>
+          <a:xfrm>
+            <a:off x="1645920" y="713232"/>
             <a:ext cx="5486400" cy="365760"/>
           </a:xfrm>
           <a:prstGeom prst="rect">
@@ -1722,13 +1746,13 @@
       </p:sp>
       <p:sp>
         <p:nvSpPr>
-          <p:cNvPr id="7" name="Text 5"/>
-          <p:cNvSpPr/>
-          <p:nvPr/>
-        </p:nvSpPr>
-        <p:spPr>
-          <a:xfrm>
-            <a:off x="777240" y="1078992"/>
+          <p:cNvPr id="8" name="Text 5"/>
+          <p:cNvSpPr/>
+          <p:nvPr/>
+        </p:nvSpPr>
+        <p:spPr>
+          <a:xfrm>
+            <a:off x="1645920" y="1106424"/>
             <a:ext cx="5486400" cy="274320"/>
           </a:xfrm>
           <a:prstGeom prst="rect">
@@ -1761,7 +1785,7 @@
       </p:sp>
       <p:sp>
         <p:nvSpPr>
-          <p:cNvPr id="8" name="Text 6"/>
+          <p:cNvPr id="9" name="Text 6"/>
           <p:cNvSpPr/>
           <p:nvPr/>
         </p:nvSpPr>
@@ -1838,7 +1862,7 @@
       </p:sp>
       <p:sp>
         <p:nvSpPr>
-          <p:cNvPr id="9" name="Text 7"/>
+          <p:cNvPr id="10" name="Text 7"/>
           <p:cNvSpPr/>
           <p:nvPr/>
         </p:nvSpPr>
@@ -1900,7 +1924,7 @@
       </p:sp>
       <p:sp>
         <p:nvSpPr>
-          <p:cNvPr id="10" name="Shape 8"/>
+          <p:cNvPr id="11" name="Shape 8"/>
           <p:cNvSpPr/>
           <p:nvPr/>
         </p:nvSpPr>
@@ -1922,7 +1946,7 @@
       </p:sp>
       <p:sp>
         <p:nvSpPr>
-          <p:cNvPr id="11" name="Text 9"/>
+          <p:cNvPr id="12" name="Text 9"/>
           <p:cNvSpPr/>
           <p:nvPr/>
         </p:nvSpPr>
@@ -1961,7 +1985,7 @@
       </p:sp>
       <p:sp>
         <p:nvSpPr>
-          <p:cNvPr id="12" name="Text 10"/>
+          <p:cNvPr id="13" name="Text 10"/>
           <p:cNvSpPr/>
           <p:nvPr/>
         </p:nvSpPr>
@@ -2000,7 +2024,7 @@
       </p:sp>
       <p:sp>
         <p:nvSpPr>
-          <p:cNvPr id="13" name="Shape 11"/>
+          <p:cNvPr id="14" name="Shape 11"/>
           <p:cNvSpPr/>
           <p:nvPr/>
         </p:nvSpPr>
@@ -2022,7 +2046,7 @@
       </p:sp>
       <p:sp>
         <p:nvSpPr>
-          <p:cNvPr id="14" name="Text 12"/>
+          <p:cNvPr id="15" name="Text 12"/>
           <p:cNvSpPr/>
           <p:nvPr/>
         </p:nvSpPr>
@@ -2061,7 +2085,7 @@
       </p:sp>
       <p:sp>
         <p:nvSpPr>
-          <p:cNvPr id="15" name="Text 13"/>
+          <p:cNvPr id="16" name="Text 13"/>
           <p:cNvSpPr/>
           <p:nvPr/>
         </p:nvSpPr>
@@ -2100,7 +2124,7 @@
       </p:sp>
       <p:sp>
         <p:nvSpPr>
-          <p:cNvPr id="16" name="Shape 14"/>
+          <p:cNvPr id="17" name="Shape 14"/>
           <p:cNvSpPr/>
           <p:nvPr/>
         </p:nvSpPr>
@@ -2122,7 +2146,7 @@
       </p:sp>
       <p:sp>
         <p:nvSpPr>
-          <p:cNvPr id="17" name="Text 15"/>
+          <p:cNvPr id="18" name="Text 15"/>
           <p:cNvSpPr/>
           <p:nvPr/>
         </p:nvSpPr>
@@ -2161,7 +2185,7 @@
       </p:sp>
       <p:sp>
         <p:nvSpPr>
-          <p:cNvPr id="18" name="Text 16"/>
+          <p:cNvPr id="19" name="Text 16"/>
           <p:cNvSpPr/>
           <p:nvPr/>
         </p:nvSpPr>
@@ -2200,7 +2224,7 @@
       </p:sp>
       <p:sp>
         <p:nvSpPr>
-          <p:cNvPr id="19" name="Shape 17"/>
+          <p:cNvPr id="20" name="Shape 17"/>
           <p:cNvSpPr/>
           <p:nvPr/>
         </p:nvSpPr>
@@ -2222,7 +2246,7 @@
       </p:sp>
       <p:sp>
         <p:nvSpPr>
-          <p:cNvPr id="20" name="Text 18"/>
+          <p:cNvPr id="21" name="Text 18"/>
           <p:cNvSpPr/>
           <p:nvPr/>
         </p:nvSpPr>
@@ -2261,7 +2285,7 @@
       </p:sp>
       <p:sp>
         <p:nvSpPr>
-          <p:cNvPr id="21" name="Text 19"/>
+          <p:cNvPr id="22" name="Text 19"/>
           <p:cNvSpPr/>
           <p:nvPr/>
         </p:nvSpPr>
@@ -2300,7 +2324,7 @@
       </p:sp>
       <p:sp>
         <p:nvSpPr>
-          <p:cNvPr id="22" name="Text 20"/>
+          <p:cNvPr id="23" name="Text 20"/>
           <p:cNvSpPr/>
           <p:nvPr/>
         </p:nvSpPr>
@@ -2369,15 +2393,39 @@
           <a:chExt cx="0" cy="0"/>
         </a:xfrm>
       </p:grpSpPr>
-      <p:sp>
-        <p:nvSpPr>
-          <p:cNvPr id="2" name="Text 0"/>
-          <p:cNvSpPr/>
-          <p:nvPr/>
-        </p:nvSpPr>
-        <p:spPr>
-          <a:xfrm>
-            <a:off x="502920" y="292608"/>
+      <p:pic>
+        <p:nvPicPr>
+          <p:cNvPr id="2" name="Image 0" descr="preencoded.png">    </p:cNvPr>
+          <p:cNvPicPr>
+            <a:picLocks noChangeAspect="1"/>
+          </p:cNvPicPr>
+          <p:nvPr/>
+        </p:nvPicPr>
+        <p:blipFill>
+          <a:blip r:embed="rId1"/>
+          <a:stretch>
+            <a:fillRect/>
+          </a:stretch>
+        </p:blipFill>
+        <p:spPr>
+          <a:xfrm>
+            <a:off x="502920" y="228600"/>
+            <a:ext cx="329184" cy="292608"/>
+          </a:xfrm>
+          <a:prstGeom prst="rect">
+            <a:avLst/>
+          </a:prstGeom>
+        </p:spPr>
+      </p:pic>
+      <p:sp>
+        <p:nvSpPr>
+          <p:cNvPr id="3" name="Text 0"/>
+          <p:cNvSpPr/>
+          <p:nvPr/>
+        </p:nvSpPr>
+        <p:spPr>
+          <a:xfrm>
+            <a:off x="932688" y="292608"/>
             <a:ext cx="3657600" cy="274320"/>
           </a:xfrm>
           <a:prstGeom prst="rect">
@@ -2410,7 +2458,7 @@
       </p:sp>
       <p:sp>
         <p:nvSpPr>
-          <p:cNvPr id="3" name="Text 1"/>
+          <p:cNvPr id="4" name="Text 1"/>
           <p:cNvSpPr/>
           <p:nvPr/>
         </p:nvSpPr>
@@ -2449,7 +2497,7 @@
       </p:sp>
       <p:sp>
         <p:nvSpPr>
-          <p:cNvPr id="4" name="Text 2"/>
+          <p:cNvPr id="5" name="Text 2"/>
           <p:cNvSpPr/>
           <p:nvPr/>
         </p:nvSpPr>
@@ -2488,7 +2536,7 @@
       </p:sp>
       <p:sp>
         <p:nvSpPr>
-          <p:cNvPr id="5" name="Shape 3"/>
+          <p:cNvPr id="6" name="Shape 3"/>
           <p:cNvSpPr/>
           <p:nvPr/>
         </p:nvSpPr>
@@ -2522,7 +2570,7 @@
       </p:sp>
       <p:sp>
         <p:nvSpPr>
-          <p:cNvPr id="6" name="Text 4"/>
+          <p:cNvPr id="7" name="Text 4"/>
           <p:cNvSpPr/>
           <p:nvPr/>
         </p:nvSpPr>
@@ -2561,7 +2609,7 @@
       </p:sp>
       <p:sp>
         <p:nvSpPr>
-          <p:cNvPr id="7" name="Text 5"/>
+          <p:cNvPr id="8" name="Text 5"/>
           <p:cNvSpPr/>
           <p:nvPr/>
         </p:nvSpPr>
@@ -2617,7 +2665,7 @@
       </p:sp>
       <p:sp>
         <p:nvSpPr>
-          <p:cNvPr id="8" name="Shape 6"/>
+          <p:cNvPr id="9" name="Shape 6"/>
           <p:cNvSpPr/>
           <p:nvPr/>
         </p:nvSpPr>
@@ -2651,7 +2699,7 @@
       </p:sp>
       <p:sp>
         <p:nvSpPr>
-          <p:cNvPr id="9" name="Text 7"/>
+          <p:cNvPr id="10" name="Text 7"/>
           <p:cNvSpPr/>
           <p:nvPr/>
         </p:nvSpPr>
@@ -2690,7 +2738,7 @@
       </p:sp>
       <p:sp>
         <p:nvSpPr>
-          <p:cNvPr id="10" name="Text 8"/>
+          <p:cNvPr id="11" name="Text 8"/>
           <p:cNvSpPr/>
           <p:nvPr/>
         </p:nvSpPr>
@@ -2746,7 +2794,7 @@
       </p:sp>
       <p:sp>
         <p:nvSpPr>
-          <p:cNvPr id="11" name="Shape 9"/>
+          <p:cNvPr id="12" name="Shape 9"/>
           <p:cNvSpPr/>
           <p:nvPr/>
         </p:nvSpPr>
@@ -2780,7 +2828,7 @@
       </p:sp>
       <p:sp>
         <p:nvSpPr>
-          <p:cNvPr id="12" name="Text 10"/>
+          <p:cNvPr id="13" name="Text 10"/>
           <p:cNvSpPr/>
           <p:nvPr/>
         </p:nvSpPr>
@@ -2819,7 +2867,7 @@
       </p:sp>
       <p:sp>
         <p:nvSpPr>
-          <p:cNvPr id="13" name="Text 11"/>
+          <p:cNvPr id="14" name="Text 11"/>
           <p:cNvSpPr/>
           <p:nvPr/>
         </p:nvSpPr>
@@ -2875,7 +2923,7 @@
       </p:sp>
       <p:sp>
         <p:nvSpPr>
-          <p:cNvPr id="14" name="Shape 12"/>
+          <p:cNvPr id="15" name="Shape 12"/>
           <p:cNvSpPr/>
           <p:nvPr/>
         </p:nvSpPr>
@@ -2902,7 +2950,7 @@
       </p:sp>
       <p:sp>
         <p:nvSpPr>
-          <p:cNvPr id="15" name="Text 13"/>
+          <p:cNvPr id="16" name="Text 13"/>
           <p:cNvSpPr/>
           <p:nvPr/>
         </p:nvSpPr>
@@ -2941,7 +2989,7 @@
       </p:sp>
       <p:sp>
         <p:nvSpPr>
-          <p:cNvPr id="16" name="Shape 14"/>
+          <p:cNvPr id="17" name="Shape 14"/>
           <p:cNvSpPr/>
           <p:nvPr/>
         </p:nvSpPr>
@@ -2961,7 +3009,7 @@
       </p:sp>
       <p:sp>
         <p:nvSpPr>
-          <p:cNvPr id="17" name="Text 15"/>
+          <p:cNvPr id="18" name="Text 15"/>
           <p:cNvSpPr/>
           <p:nvPr/>
         </p:nvSpPr>
@@ -3020,7 +3068,7 @@
       </p:sp>
       <p:sp>
         <p:nvSpPr>
-          <p:cNvPr id="18" name="Shape 16"/>
+          <p:cNvPr id="19" name="Shape 16"/>
           <p:cNvSpPr/>
           <p:nvPr/>
         </p:nvSpPr>
@@ -3040,7 +3088,7 @@
       </p:sp>
       <p:sp>
         <p:nvSpPr>
-          <p:cNvPr id="19" name="Text 17"/>
+          <p:cNvPr id="20" name="Text 17"/>
           <p:cNvSpPr/>
           <p:nvPr/>
         </p:nvSpPr>
@@ -3099,7 +3147,7 @@
       </p:sp>
       <p:sp>
         <p:nvSpPr>
-          <p:cNvPr id="20" name="Shape 18"/>
+          <p:cNvPr id="21" name="Shape 18"/>
           <p:cNvSpPr/>
           <p:nvPr/>
         </p:nvSpPr>
@@ -3119,7 +3167,7 @@
       </p:sp>
       <p:sp>
         <p:nvSpPr>
-          <p:cNvPr id="21" name="Text 19"/>
+          <p:cNvPr id="22" name="Text 19"/>
           <p:cNvSpPr/>
           <p:nvPr/>
         </p:nvSpPr>
@@ -3178,7 +3226,7 @@
       </p:sp>
       <p:sp>
         <p:nvSpPr>
-          <p:cNvPr id="22" name="Shape 20"/>
+          <p:cNvPr id="23" name="Shape 20"/>
           <p:cNvSpPr/>
           <p:nvPr/>
         </p:nvSpPr>
@@ -3200,7 +3248,7 @@
       </p:sp>
       <p:sp>
         <p:nvSpPr>
-          <p:cNvPr id="23" name="Text 21"/>
+          <p:cNvPr id="24" name="Text 21"/>
           <p:cNvSpPr/>
           <p:nvPr/>
         </p:nvSpPr>
@@ -3239,7 +3287,7 @@
       </p:sp>
       <p:sp>
         <p:nvSpPr>
-          <p:cNvPr id="24" name="Text 22"/>
+          <p:cNvPr id="25" name="Text 22"/>
           <p:cNvSpPr/>
           <p:nvPr/>
         </p:nvSpPr>
@@ -3327,7 +3375,7 @@
       </p:sp>
       <p:sp>
         <p:nvSpPr>
-          <p:cNvPr id="25" name="Text 23"/>
+          <p:cNvPr id="26" name="Text 23"/>
           <p:cNvSpPr/>
           <p:nvPr/>
         </p:nvSpPr>
@@ -3366,7 +3414,7 @@
       </p:sp>
       <p:sp>
         <p:nvSpPr>
-          <p:cNvPr id="26" name="Text 24"/>
+          <p:cNvPr id="27" name="Text 24"/>
           <p:cNvSpPr/>
           <p:nvPr/>
         </p:nvSpPr>
@@ -3435,15 +3483,39 @@
           <a:chExt cx="0" cy="0"/>
         </a:xfrm>
       </p:grpSpPr>
-      <p:sp>
-        <p:nvSpPr>
-          <p:cNvPr id="2" name="Text 0"/>
-          <p:cNvSpPr/>
-          <p:nvPr/>
-        </p:nvSpPr>
-        <p:spPr>
-          <a:xfrm>
-            <a:off x="502920" y="292608"/>
+      <p:pic>
+        <p:nvPicPr>
+          <p:cNvPr id="2" name="Image 0" descr="preencoded.png">    </p:cNvPr>
+          <p:cNvPicPr>
+            <a:picLocks noChangeAspect="1"/>
+          </p:cNvPicPr>
+          <p:nvPr/>
+        </p:nvPicPr>
+        <p:blipFill>
+          <a:blip r:embed="rId1"/>
+          <a:stretch>
+            <a:fillRect/>
+          </a:stretch>
+        </p:blipFill>
+        <p:spPr>
+          <a:xfrm>
+            <a:off x="502920" y="228600"/>
+            <a:ext cx="329184" cy="292608"/>
+          </a:xfrm>
+          <a:prstGeom prst="rect">
+            <a:avLst/>
+          </a:prstGeom>
+        </p:spPr>
+      </p:pic>
+      <p:sp>
+        <p:nvSpPr>
+          <p:cNvPr id="3" name="Text 0"/>
+          <p:cNvSpPr/>
+          <p:nvPr/>
+        </p:nvSpPr>
+        <p:spPr>
+          <a:xfrm>
+            <a:off x="932688" y="292608"/>
             <a:ext cx="3657600" cy="274320"/>
           </a:xfrm>
           <a:prstGeom prst="rect">
@@ -3476,7 +3548,7 @@
       </p:sp>
       <p:sp>
         <p:nvSpPr>
-          <p:cNvPr id="3" name="Text 1"/>
+          <p:cNvPr id="4" name="Text 1"/>
           <p:cNvSpPr/>
           <p:nvPr/>
         </p:nvSpPr>
@@ -3515,7 +3587,7 @@
       </p:sp>
       <p:sp>
         <p:nvSpPr>
-          <p:cNvPr id="4" name="Text 2"/>
+          <p:cNvPr id="5" name="Text 2"/>
           <p:cNvSpPr/>
           <p:nvPr/>
         </p:nvSpPr>
@@ -3554,7 +3626,7 @@
       </p:sp>
       <p:sp>
         <p:nvSpPr>
-          <p:cNvPr id="5" name="Shape 3"/>
+          <p:cNvPr id="6" name="Shape 3"/>
           <p:cNvSpPr/>
           <p:nvPr/>
         </p:nvSpPr>
@@ -3581,7 +3653,7 @@
       </p:sp>
       <p:sp>
         <p:nvSpPr>
-          <p:cNvPr id="6" name="Text 4"/>
+          <p:cNvPr id="7" name="Text 4"/>
           <p:cNvSpPr/>
           <p:nvPr/>
         </p:nvSpPr>
@@ -3620,7 +3692,7 @@
       </p:sp>
       <p:sp>
         <p:nvSpPr>
-          <p:cNvPr id="7" name="Text 5"/>
+          <p:cNvPr id="8" name="Text 5"/>
           <p:cNvSpPr/>
           <p:nvPr/>
         </p:nvSpPr>
@@ -3659,7 +3731,7 @@
       </p:sp>
       <p:sp>
         <p:nvSpPr>
-          <p:cNvPr id="8" name="Shape 6"/>
+          <p:cNvPr id="9" name="Shape 6"/>
           <p:cNvSpPr/>
           <p:nvPr/>
         </p:nvSpPr>
@@ -3681,7 +3753,7 @@
       </p:sp>
       <p:sp>
         <p:nvSpPr>
-          <p:cNvPr id="9" name="Text 7"/>
+          <p:cNvPr id="10" name="Text 7"/>
           <p:cNvSpPr/>
           <p:nvPr/>
         </p:nvSpPr>
@@ -3720,7 +3792,7 @@
       </p:sp>
       <p:sp>
         <p:nvSpPr>
-          <p:cNvPr id="10" name="Shape 8"/>
+          <p:cNvPr id="11" name="Shape 8"/>
           <p:cNvSpPr/>
           <p:nvPr/>
         </p:nvSpPr>
@@ -3742,7 +3814,7 @@
       </p:sp>
       <p:sp>
         <p:nvSpPr>
-          <p:cNvPr id="11" name="Text 9"/>
+          <p:cNvPr id="12" name="Text 9"/>
           <p:cNvSpPr/>
           <p:nvPr/>
         </p:nvSpPr>
@@ -3781,7 +3853,7 @@
       </p:sp>
       <p:sp>
         <p:nvSpPr>
-          <p:cNvPr id="12" name="Text 10"/>
+          <p:cNvPr id="13" name="Text 10"/>
           <p:cNvSpPr/>
           <p:nvPr/>
         </p:nvSpPr>
@@ -3820,7 +3892,7 @@
       </p:sp>
       <p:sp>
         <p:nvSpPr>
-          <p:cNvPr id="13" name="Shape 11"/>
+          <p:cNvPr id="14" name="Shape 11"/>
           <p:cNvSpPr/>
           <p:nvPr/>
         </p:nvSpPr>
@@ -3842,7 +3914,7 @@
       </p:sp>
       <p:sp>
         <p:nvSpPr>
-          <p:cNvPr id="14" name="Text 12"/>
+          <p:cNvPr id="15" name="Text 12"/>
           <p:cNvSpPr/>
           <p:nvPr/>
         </p:nvSpPr>
@@ -3881,7 +3953,7 @@
       </p:sp>
       <p:sp>
         <p:nvSpPr>
-          <p:cNvPr id="15" name="Shape 13"/>
+          <p:cNvPr id="16" name="Shape 13"/>
           <p:cNvSpPr/>
           <p:nvPr/>
         </p:nvSpPr>
@@ -3903,7 +3975,7 @@
       </p:sp>
       <p:sp>
         <p:nvSpPr>
-          <p:cNvPr id="16" name="Text 14"/>
+          <p:cNvPr id="17" name="Text 14"/>
           <p:cNvSpPr/>
           <p:nvPr/>
         </p:nvSpPr>
@@ -3942,7 +4014,7 @@
       </p:sp>
       <p:sp>
         <p:nvSpPr>
-          <p:cNvPr id="17" name="Text 15"/>
+          <p:cNvPr id="18" name="Text 15"/>
           <p:cNvSpPr/>
           <p:nvPr/>
         </p:nvSpPr>
@@ -3981,7 +4053,7 @@
       </p:sp>
       <p:sp>
         <p:nvSpPr>
-          <p:cNvPr id="18" name="Shape 16"/>
+          <p:cNvPr id="19" name="Shape 16"/>
           <p:cNvSpPr/>
           <p:nvPr/>
         </p:nvSpPr>
@@ -4003,7 +4075,7 @@
       </p:sp>
       <p:sp>
         <p:nvSpPr>
-          <p:cNvPr id="19" name="Text 17"/>
+          <p:cNvPr id="20" name="Text 17"/>
           <p:cNvSpPr/>
           <p:nvPr/>
         </p:nvSpPr>
@@ -4042,7 +4114,7 @@
       </p:sp>
       <p:sp>
         <p:nvSpPr>
-          <p:cNvPr id="20" name="Shape 18"/>
+          <p:cNvPr id="21" name="Shape 18"/>
           <p:cNvSpPr/>
           <p:nvPr/>
         </p:nvSpPr>
@@ -4064,7 +4136,7 @@
       </p:sp>
       <p:sp>
         <p:nvSpPr>
-          <p:cNvPr id="21" name="Text 19"/>
+          <p:cNvPr id="22" name="Text 19"/>
           <p:cNvSpPr/>
           <p:nvPr/>
         </p:nvSpPr>
@@ -4103,7 +4175,7 @@
       </p:sp>
       <p:sp>
         <p:nvSpPr>
-          <p:cNvPr id="22" name="Text 20"/>
+          <p:cNvPr id="23" name="Text 20"/>
           <p:cNvSpPr/>
           <p:nvPr/>
         </p:nvSpPr>
@@ -4142,7 +4214,7 @@
       </p:sp>
       <p:sp>
         <p:nvSpPr>
-          <p:cNvPr id="23" name="Shape 21"/>
+          <p:cNvPr id="24" name="Shape 21"/>
           <p:cNvSpPr/>
           <p:nvPr/>
         </p:nvSpPr>
@@ -4164,7 +4236,7 @@
       </p:sp>
       <p:sp>
         <p:nvSpPr>
-          <p:cNvPr id="24" name="Text 22"/>
+          <p:cNvPr id="25" name="Text 22"/>
           <p:cNvSpPr/>
           <p:nvPr/>
         </p:nvSpPr>
@@ -4203,7 +4275,7 @@
       </p:sp>
       <p:sp>
         <p:nvSpPr>
-          <p:cNvPr id="25" name="Shape 23"/>
+          <p:cNvPr id="26" name="Shape 23"/>
           <p:cNvSpPr/>
           <p:nvPr/>
         </p:nvSpPr>
@@ -4225,7 +4297,7 @@
       </p:sp>
       <p:sp>
         <p:nvSpPr>
-          <p:cNvPr id="26" name="Text 24"/>
+          <p:cNvPr id="27" name="Text 24"/>
           <p:cNvSpPr/>
           <p:nvPr/>
         </p:nvSpPr>
@@ -4264,7 +4336,7 @@
       </p:sp>
       <p:sp>
         <p:nvSpPr>
-          <p:cNvPr id="27" name="Shape 25"/>
+          <p:cNvPr id="28" name="Shape 25"/>
           <p:cNvSpPr/>
           <p:nvPr/>
         </p:nvSpPr>
@@ -4291,7 +4363,7 @@
       </p:sp>
       <p:sp>
         <p:nvSpPr>
-          <p:cNvPr id="28" name="Text 26"/>
+          <p:cNvPr id="29" name="Text 26"/>
           <p:cNvSpPr/>
           <p:nvPr/>
         </p:nvSpPr>
@@ -4330,7 +4402,7 @@
       </p:sp>
       <p:graphicFrame>
         <p:nvGraphicFramePr>
-          <p:cNvPr id="29" name="Chart 0" descr=""/>
+          <p:cNvPr id="30" name="Chart 0" descr=""/>
           <p:cNvGraphicFramePr/>
           <p:nvPr/>
         </p:nvGraphicFramePr>
@@ -4340,13 +4412,13 @@
         </p:xfrm>
         <a:graphic xmlns:a="http://schemas.openxmlformats.org/drawingml/2006/main">
           <a:graphicData uri="http://schemas.openxmlformats.org/drawingml/2006/chart">
-            <c:chart xmlns:c="http://schemas.openxmlformats.org/drawingml/2006/chart" r:id="rId1"/>
+            <c:chart xmlns:c="http://schemas.openxmlformats.org/drawingml/2006/chart" r:id="rId2"/>
           </a:graphicData>
         </a:graphic>
       </p:graphicFrame>
       <p:sp>
         <p:nvSpPr>
-          <p:cNvPr id="30" name="Shape 27"/>
+          <p:cNvPr id="31" name="Shape 27"/>
           <p:cNvSpPr/>
           <p:nvPr/>
         </p:nvSpPr>
@@ -4368,7 +4440,7 @@
       </p:sp>
       <p:sp>
         <p:nvSpPr>
-          <p:cNvPr id="31" name="Text 28"/>
+          <p:cNvPr id="32" name="Text 28"/>
           <p:cNvSpPr/>
           <p:nvPr/>
         </p:nvSpPr>
@@ -4461,7 +4533,7 @@
       </p:sp>
       <p:sp>
         <p:nvSpPr>
-          <p:cNvPr id="32" name="Text 29"/>
+          <p:cNvPr id="33" name="Text 29"/>
           <p:cNvSpPr/>
           <p:nvPr/>
         </p:nvSpPr>
@@ -4500,7 +4572,7 @@
       </p:sp>
       <p:sp>
         <p:nvSpPr>
-          <p:cNvPr id="33" name="Text 30"/>
+          <p:cNvPr id="34" name="Text 30"/>
           <p:cNvSpPr/>
           <p:nvPr/>
         </p:nvSpPr>
@@ -4569,15 +4641,39 @@
           <a:chExt cx="0" cy="0"/>
         </a:xfrm>
       </p:grpSpPr>
-      <p:sp>
-        <p:nvSpPr>
-          <p:cNvPr id="2" name="Text 0"/>
-          <p:cNvSpPr/>
-          <p:nvPr/>
-        </p:nvSpPr>
-        <p:spPr>
-          <a:xfrm>
-            <a:off x="502920" y="292608"/>
+      <p:pic>
+        <p:nvPicPr>
+          <p:cNvPr id="2" name="Image 0" descr="preencoded.png">    </p:cNvPr>
+          <p:cNvPicPr>
+            <a:picLocks noChangeAspect="1"/>
+          </p:cNvPicPr>
+          <p:nvPr/>
+        </p:nvPicPr>
+        <p:blipFill>
+          <a:blip r:embed="rId1"/>
+          <a:stretch>
+            <a:fillRect/>
+          </a:stretch>
+        </p:blipFill>
+        <p:spPr>
+          <a:xfrm>
+            <a:off x="502920" y="228600"/>
+            <a:ext cx="329184" cy="292608"/>
+          </a:xfrm>
+          <a:prstGeom prst="rect">
+            <a:avLst/>
+          </a:prstGeom>
+        </p:spPr>
+      </p:pic>
+      <p:sp>
+        <p:nvSpPr>
+          <p:cNvPr id="3" name="Text 0"/>
+          <p:cNvSpPr/>
+          <p:nvPr/>
+        </p:nvSpPr>
+        <p:spPr>
+          <a:xfrm>
+            <a:off x="932688" y="292608"/>
             <a:ext cx="3657600" cy="274320"/>
           </a:xfrm>
           <a:prstGeom prst="rect">
@@ -4610,7 +4706,7 @@
       </p:sp>
       <p:sp>
         <p:nvSpPr>
-          <p:cNvPr id="3" name="Text 1"/>
+          <p:cNvPr id="4" name="Text 1"/>
           <p:cNvSpPr/>
           <p:nvPr/>
         </p:nvSpPr>
@@ -4649,7 +4745,7 @@
       </p:sp>
       <p:sp>
         <p:nvSpPr>
-          <p:cNvPr id="4" name="Text 2"/>
+          <p:cNvPr id="5" name="Text 2"/>
           <p:cNvSpPr/>
           <p:nvPr/>
         </p:nvSpPr>
@@ -4688,7 +4784,7 @@
       </p:sp>
       <p:sp>
         <p:nvSpPr>
-          <p:cNvPr id="5" name="Shape 3"/>
+          <p:cNvPr id="6" name="Shape 3"/>
           <p:cNvSpPr/>
           <p:nvPr/>
         </p:nvSpPr>
@@ -4722,7 +4818,7 @@
       </p:sp>
       <p:sp>
         <p:nvSpPr>
-          <p:cNvPr id="6" name="Text 4"/>
+          <p:cNvPr id="7" name="Text 4"/>
           <p:cNvSpPr/>
           <p:nvPr/>
         </p:nvSpPr>
@@ -4761,7 +4857,7 @@
       </p:sp>
       <p:sp>
         <p:nvSpPr>
-          <p:cNvPr id="7" name="Text 5"/>
+          <p:cNvPr id="8" name="Text 5"/>
           <p:cNvSpPr/>
           <p:nvPr/>
         </p:nvSpPr>
@@ -4817,7 +4913,7 @@
       </p:sp>
       <p:sp>
         <p:nvSpPr>
-          <p:cNvPr id="8" name="Shape 6"/>
+          <p:cNvPr id="9" name="Shape 6"/>
           <p:cNvSpPr/>
           <p:nvPr/>
         </p:nvSpPr>
@@ -4851,7 +4947,7 @@
       </p:sp>
       <p:sp>
         <p:nvSpPr>
-          <p:cNvPr id="9" name="Text 7"/>
+          <p:cNvPr id="10" name="Text 7"/>
           <p:cNvSpPr/>
           <p:nvPr/>
         </p:nvSpPr>
@@ -4890,7 +4986,7 @@
       </p:sp>
       <p:sp>
         <p:nvSpPr>
-          <p:cNvPr id="10" name="Text 8"/>
+          <p:cNvPr id="11" name="Text 8"/>
           <p:cNvSpPr/>
           <p:nvPr/>
         </p:nvSpPr>
@@ -4946,7 +5042,7 @@
       </p:sp>
       <p:sp>
         <p:nvSpPr>
-          <p:cNvPr id="11" name="Shape 9"/>
+          <p:cNvPr id="12" name="Shape 9"/>
           <p:cNvSpPr/>
           <p:nvPr/>
         </p:nvSpPr>
@@ -4980,7 +5076,7 @@
       </p:sp>
       <p:sp>
         <p:nvSpPr>
-          <p:cNvPr id="12" name="Text 10"/>
+          <p:cNvPr id="13" name="Text 10"/>
           <p:cNvSpPr/>
           <p:nvPr/>
         </p:nvSpPr>
@@ -5019,7 +5115,7 @@
       </p:sp>
       <p:sp>
         <p:nvSpPr>
-          <p:cNvPr id="13" name="Text 11"/>
+          <p:cNvPr id="14" name="Text 11"/>
           <p:cNvSpPr/>
           <p:nvPr/>
         </p:nvSpPr>
@@ -5075,7 +5171,7 @@
       </p:sp>
       <p:sp>
         <p:nvSpPr>
-          <p:cNvPr id="14" name="Shape 12"/>
+          <p:cNvPr id="15" name="Shape 12"/>
           <p:cNvSpPr/>
           <p:nvPr/>
         </p:nvSpPr>
@@ -5109,7 +5205,7 @@
       </p:sp>
       <p:sp>
         <p:nvSpPr>
-          <p:cNvPr id="15" name="Text 13"/>
+          <p:cNvPr id="16" name="Text 13"/>
           <p:cNvSpPr/>
           <p:nvPr/>
         </p:nvSpPr>
@@ -5148,7 +5244,7 @@
       </p:sp>
       <p:sp>
         <p:nvSpPr>
-          <p:cNvPr id="16" name="Text 14"/>
+          <p:cNvPr id="17" name="Text 14"/>
           <p:cNvSpPr/>
           <p:nvPr/>
         </p:nvSpPr>
@@ -5204,7 +5300,7 @@
       </p:sp>
       <p:sp>
         <p:nvSpPr>
-          <p:cNvPr id="17" name="Shape 15"/>
+          <p:cNvPr id="18" name="Shape 15"/>
           <p:cNvSpPr/>
           <p:nvPr/>
         </p:nvSpPr>
@@ -5231,7 +5327,7 @@
       </p:sp>
       <p:sp>
         <p:nvSpPr>
-          <p:cNvPr id="18" name="Text 16"/>
+          <p:cNvPr id="19" name="Text 16"/>
           <p:cNvSpPr/>
           <p:nvPr/>
         </p:nvSpPr>
@@ -5270,7 +5366,7 @@
       </p:sp>
       <p:sp>
         <p:nvSpPr>
-          <p:cNvPr id="19" name="Shape 17"/>
+          <p:cNvPr id="20" name="Shape 17"/>
           <p:cNvSpPr/>
           <p:nvPr/>
         </p:nvSpPr>
@@ -5290,7 +5386,7 @@
       </p:sp>
       <p:sp>
         <p:nvSpPr>
-          <p:cNvPr id="20" name="Text 18"/>
+          <p:cNvPr id="21" name="Text 18"/>
           <p:cNvSpPr/>
           <p:nvPr/>
         </p:nvSpPr>
@@ -5329,7 +5425,7 @@
       </p:sp>
       <p:sp>
         <p:nvSpPr>
-          <p:cNvPr id="21" name="Text 19"/>
+          <p:cNvPr id="22" name="Text 19"/>
           <p:cNvSpPr/>
           <p:nvPr/>
         </p:nvSpPr>
@@ -5388,7 +5484,7 @@
       </p:sp>
       <p:sp>
         <p:nvSpPr>
-          <p:cNvPr id="22" name="Shape 20"/>
+          <p:cNvPr id="23" name="Shape 20"/>
           <p:cNvSpPr/>
           <p:nvPr/>
         </p:nvSpPr>
@@ -5408,7 +5504,7 @@
       </p:sp>
       <p:sp>
         <p:nvSpPr>
-          <p:cNvPr id="23" name="Text 21"/>
+          <p:cNvPr id="24" name="Text 21"/>
           <p:cNvSpPr/>
           <p:nvPr/>
         </p:nvSpPr>
@@ -5447,7 +5543,7 @@
       </p:sp>
       <p:sp>
         <p:nvSpPr>
-          <p:cNvPr id="24" name="Text 22"/>
+          <p:cNvPr id="25" name="Text 22"/>
           <p:cNvSpPr/>
           <p:nvPr/>
         </p:nvSpPr>
@@ -5506,7 +5602,7 @@
       </p:sp>
       <p:sp>
         <p:nvSpPr>
-          <p:cNvPr id="25" name="Shape 23"/>
+          <p:cNvPr id="26" name="Shape 23"/>
           <p:cNvSpPr/>
           <p:nvPr/>
         </p:nvSpPr>
@@ -5526,7 +5622,7 @@
       </p:sp>
       <p:sp>
         <p:nvSpPr>
-          <p:cNvPr id="26" name="Text 24"/>
+          <p:cNvPr id="27" name="Text 24"/>
           <p:cNvSpPr/>
           <p:nvPr/>
         </p:nvSpPr>
@@ -5565,7 +5661,7 @@
       </p:sp>
       <p:sp>
         <p:nvSpPr>
-          <p:cNvPr id="27" name="Text 25"/>
+          <p:cNvPr id="28" name="Text 25"/>
           <p:cNvSpPr/>
           <p:nvPr/>
         </p:nvSpPr>
@@ -5624,7 +5720,7 @@
       </p:sp>
       <p:sp>
         <p:nvSpPr>
-          <p:cNvPr id="28" name="Shape 26"/>
+          <p:cNvPr id="29" name="Shape 26"/>
           <p:cNvSpPr/>
           <p:nvPr/>
         </p:nvSpPr>
@@ -5646,7 +5742,7 @@
       </p:sp>
       <p:sp>
         <p:nvSpPr>
-          <p:cNvPr id="29" name="Text 27"/>
+          <p:cNvPr id="30" name="Text 27"/>
           <p:cNvSpPr/>
           <p:nvPr/>
         </p:nvSpPr>
@@ -5685,7 +5781,7 @@
       </p:sp>
       <p:sp>
         <p:nvSpPr>
-          <p:cNvPr id="30" name="Text 28"/>
+          <p:cNvPr id="31" name="Text 28"/>
           <p:cNvSpPr/>
           <p:nvPr/>
         </p:nvSpPr>
@@ -5724,7 +5820,7 @@
       </p:sp>
       <p:sp>
         <p:nvSpPr>
-          <p:cNvPr id="31" name="Shape 29"/>
+          <p:cNvPr id="32" name="Shape 29"/>
           <p:cNvSpPr/>
           <p:nvPr/>
         </p:nvSpPr>
@@ -5746,7 +5842,7 @@
       </p:sp>
       <p:sp>
         <p:nvSpPr>
-          <p:cNvPr id="32" name="Text 30"/>
+          <p:cNvPr id="33" name="Text 30"/>
           <p:cNvSpPr/>
           <p:nvPr/>
         </p:nvSpPr>
@@ -5785,7 +5881,7 @@
       </p:sp>
       <p:sp>
         <p:nvSpPr>
-          <p:cNvPr id="33" name="Text 31"/>
+          <p:cNvPr id="34" name="Text 31"/>
           <p:cNvSpPr/>
           <p:nvPr/>
         </p:nvSpPr>
@@ -5824,7 +5920,7 @@
       </p:sp>
       <p:sp>
         <p:nvSpPr>
-          <p:cNvPr id="34" name="Shape 32"/>
+          <p:cNvPr id="35" name="Shape 32"/>
           <p:cNvSpPr/>
           <p:nvPr/>
         </p:nvSpPr>
@@ -5846,7 +5942,7 @@
       </p:sp>
       <p:sp>
         <p:nvSpPr>
-          <p:cNvPr id="35" name="Text 33"/>
+          <p:cNvPr id="36" name="Text 33"/>
           <p:cNvSpPr/>
           <p:nvPr/>
         </p:nvSpPr>
@@ -5885,7 +5981,7 @@
       </p:sp>
       <p:sp>
         <p:nvSpPr>
-          <p:cNvPr id="36" name="Text 34"/>
+          <p:cNvPr id="37" name="Text 34"/>
           <p:cNvSpPr/>
           <p:nvPr/>
         </p:nvSpPr>
@@ -5924,7 +6020,7 @@
       </p:sp>
       <p:sp>
         <p:nvSpPr>
-          <p:cNvPr id="37" name="Shape 35"/>
+          <p:cNvPr id="38" name="Shape 35"/>
           <p:cNvSpPr/>
           <p:nvPr/>
         </p:nvSpPr>
@@ -5946,7 +6042,7 @@
       </p:sp>
       <p:sp>
         <p:nvSpPr>
-          <p:cNvPr id="38" name="Text 36"/>
+          <p:cNvPr id="39" name="Text 36"/>
           <p:cNvSpPr/>
           <p:nvPr/>
         </p:nvSpPr>
@@ -5985,7 +6081,7 @@
       </p:sp>
       <p:sp>
         <p:nvSpPr>
-          <p:cNvPr id="39" name="Text 37"/>
+          <p:cNvPr id="40" name="Text 37"/>
           <p:cNvSpPr/>
           <p:nvPr/>
         </p:nvSpPr>
@@ -6024,7 +6120,7 @@
       </p:sp>
       <p:sp>
         <p:nvSpPr>
-          <p:cNvPr id="40" name="Shape 38"/>
+          <p:cNvPr id="41" name="Shape 38"/>
           <p:cNvSpPr/>
           <p:nvPr/>
         </p:nvSpPr>
@@ -6046,7 +6142,7 @@
       </p:sp>
       <p:sp>
         <p:nvSpPr>
-          <p:cNvPr id="41" name="Text 39"/>
+          <p:cNvPr id="42" name="Text 39"/>
           <p:cNvSpPr/>
           <p:nvPr/>
         </p:nvSpPr>
@@ -6085,7 +6181,7 @@
       </p:sp>
       <p:sp>
         <p:nvSpPr>
-          <p:cNvPr id="42" name="Text 40"/>
+          <p:cNvPr id="43" name="Text 40"/>
           <p:cNvSpPr/>
           <p:nvPr/>
         </p:nvSpPr>
@@ -6127,7 +6223,7 @@
       </p:sp>
       <p:sp>
         <p:nvSpPr>
-          <p:cNvPr id="43" name="Text 41"/>
+          <p:cNvPr id="44" name="Text 41"/>
           <p:cNvSpPr/>
           <p:nvPr/>
         </p:nvSpPr>
@@ -6166,7 +6262,7 @@
       </p:sp>
       <p:sp>
         <p:nvSpPr>
-          <p:cNvPr id="44" name="Text 42"/>
+          <p:cNvPr id="45" name="Text 42"/>
           <p:cNvSpPr/>
           <p:nvPr/>
         </p:nvSpPr>
@@ -6235,15 +6331,39 @@
           <a:chExt cx="0" cy="0"/>
         </a:xfrm>
       </p:grpSpPr>
-      <p:sp>
-        <p:nvSpPr>
-          <p:cNvPr id="2" name="Text 0"/>
-          <p:cNvSpPr/>
-          <p:nvPr/>
-        </p:nvSpPr>
-        <p:spPr>
-          <a:xfrm>
-            <a:off x="502920" y="292608"/>
+      <p:pic>
+        <p:nvPicPr>
+          <p:cNvPr id="2" name="Image 0" descr="preencoded.png">    </p:cNvPr>
+          <p:cNvPicPr>
+            <a:picLocks noChangeAspect="1"/>
+          </p:cNvPicPr>
+          <p:nvPr/>
+        </p:nvPicPr>
+        <p:blipFill>
+          <a:blip r:embed="rId1"/>
+          <a:stretch>
+            <a:fillRect/>
+          </a:stretch>
+        </p:blipFill>
+        <p:spPr>
+          <a:xfrm>
+            <a:off x="502920" y="228600"/>
+            <a:ext cx="329184" cy="292608"/>
+          </a:xfrm>
+          <a:prstGeom prst="rect">
+            <a:avLst/>
+          </a:prstGeom>
+        </p:spPr>
+      </p:pic>
+      <p:sp>
+        <p:nvSpPr>
+          <p:cNvPr id="3" name="Text 0"/>
+          <p:cNvSpPr/>
+          <p:nvPr/>
+        </p:nvSpPr>
+        <p:spPr>
+          <a:xfrm>
+            <a:off x="932688" y="292608"/>
             <a:ext cx="3657600" cy="274320"/>
           </a:xfrm>
           <a:prstGeom prst="rect">
@@ -6276,7 +6396,7 @@
       </p:sp>
       <p:sp>
         <p:nvSpPr>
-          <p:cNvPr id="3" name="Text 1"/>
+          <p:cNvPr id="4" name="Text 1"/>
           <p:cNvSpPr/>
           <p:nvPr/>
         </p:nvSpPr>
@@ -6315,7 +6435,7 @@
       </p:sp>
       <p:sp>
         <p:nvSpPr>
-          <p:cNvPr id="4" name="Text 2"/>
+          <p:cNvPr id="5" name="Text 2"/>
           <p:cNvSpPr/>
           <p:nvPr/>
         </p:nvSpPr>
@@ -6354,7 +6474,7 @@
       </p:sp>
       <p:sp>
         <p:nvSpPr>
-          <p:cNvPr id="5" name="Shape 3"/>
+          <p:cNvPr id="6" name="Shape 3"/>
           <p:cNvSpPr/>
           <p:nvPr/>
         </p:nvSpPr>
@@ -6381,7 +6501,7 @@
       </p:sp>
       <p:sp>
         <p:nvSpPr>
-          <p:cNvPr id="6" name="Text 4"/>
+          <p:cNvPr id="7" name="Text 4"/>
           <p:cNvSpPr/>
           <p:nvPr/>
         </p:nvSpPr>
@@ -6420,7 +6540,7 @@
       </p:sp>
       <p:sp>
         <p:nvSpPr>
-          <p:cNvPr id="7" name="Text 5"/>
+          <p:cNvPr id="8" name="Text 5"/>
           <p:cNvSpPr/>
           <p:nvPr/>
         </p:nvSpPr>
@@ -6459,7 +6579,7 @@
       </p:sp>
       <p:sp>
         <p:nvSpPr>
-          <p:cNvPr id="8" name="Text 6"/>
+          <p:cNvPr id="9" name="Text 6"/>
           <p:cNvSpPr/>
           <p:nvPr/>
         </p:nvSpPr>
@@ -6553,7 +6673,7 @@
       </p:sp>
       <p:sp>
         <p:nvSpPr>
-          <p:cNvPr id="9" name="Shape 7"/>
+          <p:cNvPr id="10" name="Shape 7"/>
           <p:cNvSpPr/>
           <p:nvPr/>
         </p:nvSpPr>
@@ -6580,7 +6700,7 @@
       </p:sp>
       <p:sp>
         <p:nvSpPr>
-          <p:cNvPr id="10" name="Text 8"/>
+          <p:cNvPr id="11" name="Text 8"/>
           <p:cNvSpPr/>
           <p:nvPr/>
         </p:nvSpPr>
@@ -6619,7 +6739,7 @@
       </p:sp>
       <p:sp>
         <p:nvSpPr>
-          <p:cNvPr id="11" name="Text 9"/>
+          <p:cNvPr id="12" name="Text 9"/>
           <p:cNvSpPr/>
           <p:nvPr/>
         </p:nvSpPr>
@@ -6658,7 +6778,7 @@
       </p:sp>
       <p:sp>
         <p:nvSpPr>
-          <p:cNvPr id="12" name="Text 10"/>
+          <p:cNvPr id="13" name="Text 10"/>
           <p:cNvSpPr/>
           <p:nvPr/>
         </p:nvSpPr>
@@ -6752,7 +6872,7 @@
       </p:sp>
       <p:sp>
         <p:nvSpPr>
-          <p:cNvPr id="13" name="Shape 11"/>
+          <p:cNvPr id="14" name="Shape 11"/>
           <p:cNvSpPr/>
           <p:nvPr/>
         </p:nvSpPr>
@@ -6779,7 +6899,7 @@
       </p:sp>
       <p:sp>
         <p:nvSpPr>
-          <p:cNvPr id="14" name="Text 12"/>
+          <p:cNvPr id="15" name="Text 12"/>
           <p:cNvSpPr/>
           <p:nvPr/>
         </p:nvSpPr>
@@ -6818,7 +6938,7 @@
       </p:sp>
       <p:sp>
         <p:nvSpPr>
-          <p:cNvPr id="15" name="Text 13"/>
+          <p:cNvPr id="16" name="Text 13"/>
           <p:cNvSpPr/>
           <p:nvPr/>
         </p:nvSpPr>
@@ -6857,7 +6977,7 @@
       </p:sp>
       <p:sp>
         <p:nvSpPr>
-          <p:cNvPr id="16" name="Text 14"/>
+          <p:cNvPr id="17" name="Text 14"/>
           <p:cNvSpPr/>
           <p:nvPr/>
         </p:nvSpPr>
@@ -6951,7 +7071,7 @@
       </p:sp>
       <p:sp>
         <p:nvSpPr>
-          <p:cNvPr id="17" name="Shape 15"/>
+          <p:cNvPr id="18" name="Shape 15"/>
           <p:cNvSpPr/>
           <p:nvPr/>
         </p:nvSpPr>
@@ -6973,7 +7093,7 @@
       </p:sp>
       <p:sp>
         <p:nvSpPr>
-          <p:cNvPr id="18" name="Text 16"/>
+          <p:cNvPr id="19" name="Text 16"/>
           <p:cNvSpPr/>
           <p:nvPr/>
         </p:nvSpPr>
@@ -7012,7 +7132,7 @@
       </p:sp>
       <p:sp>
         <p:nvSpPr>
-          <p:cNvPr id="19" name="Text 17"/>
+          <p:cNvPr id="20" name="Text 17"/>
           <p:cNvSpPr/>
           <p:nvPr/>
         </p:nvSpPr>
@@ -7170,7 +7290,7 @@
       </p:sp>
       <p:sp>
         <p:nvSpPr>
-          <p:cNvPr id="20" name="Shape 18"/>
+          <p:cNvPr id="21" name="Shape 18"/>
           <p:cNvSpPr/>
           <p:nvPr/>
         </p:nvSpPr>
@@ -7192,7 +7312,7 @@
       </p:sp>
       <p:sp>
         <p:nvSpPr>
-          <p:cNvPr id="21" name="Text 19"/>
+          <p:cNvPr id="22" name="Text 19"/>
           <p:cNvSpPr/>
           <p:nvPr/>
         </p:nvSpPr>
@@ -7251,7 +7371,7 @@
       </p:sp>
       <p:sp>
         <p:nvSpPr>
-          <p:cNvPr id="22" name="Text 20"/>
+          <p:cNvPr id="23" name="Text 20"/>
           <p:cNvSpPr/>
           <p:nvPr/>
         </p:nvSpPr>
@@ -7290,7 +7410,7 @@
       </p:sp>
       <p:sp>
         <p:nvSpPr>
-          <p:cNvPr id="23" name="Text 21"/>
+          <p:cNvPr id="24" name="Text 21"/>
           <p:cNvSpPr/>
           <p:nvPr/>
         </p:nvSpPr>
@@ -7451,15 +7571,39 @@
           <a:ln/>
         </p:spPr>
       </p:sp>
-      <p:sp>
-        <p:nvSpPr>
-          <p:cNvPr id="6" name="Text 4"/>
-          <p:cNvSpPr/>
-          <p:nvPr/>
-        </p:nvSpPr>
-        <p:spPr>
-          <a:xfrm>
-            <a:off x="777240" y="548640"/>
+      <p:pic>
+        <p:nvPicPr>
+          <p:cNvPr id="6" name="Image 0" descr="preencoded.png">    </p:cNvPr>
+          <p:cNvPicPr>
+            <a:picLocks noChangeAspect="1"/>
+          </p:cNvPicPr>
+          <p:nvPr/>
+        </p:nvPicPr>
+        <p:blipFill>
+          <a:blip r:embed="rId1"/>
+          <a:stretch>
+            <a:fillRect/>
+          </a:stretch>
+        </p:blipFill>
+        <p:spPr>
+          <a:xfrm>
+            <a:off x="777240" y="484632"/>
+            <a:ext cx="429768" cy="384048"/>
+          </a:xfrm>
+          <a:prstGeom prst="rect">
+            <a:avLst/>
+          </a:prstGeom>
+        </p:spPr>
+      </p:pic>
+      <p:sp>
+        <p:nvSpPr>
+          <p:cNvPr id="7" name="Text 4"/>
+          <p:cNvSpPr/>
+          <p:nvPr/>
+        </p:nvSpPr>
+        <p:spPr>
+          <a:xfrm>
+            <a:off x="1344168" y="521208"/>
             <a:ext cx="5486400" cy="320040"/>
           </a:xfrm>
           <a:prstGeom prst="rect">
@@ -7492,7 +7636,7 @@
       </p:sp>
       <p:sp>
         <p:nvSpPr>
-          <p:cNvPr id="7" name="Text 5"/>
+          <p:cNvPr id="8" name="Text 5"/>
           <p:cNvSpPr/>
           <p:nvPr/>
         </p:nvSpPr>
@@ -7587,7 +7731,7 @@
       </p:sp>
       <p:sp>
         <p:nvSpPr>
-          <p:cNvPr id="8" name="Text 6"/>
+          <p:cNvPr id="9" name="Text 6"/>
           <p:cNvSpPr/>
           <p:nvPr/>
         </p:nvSpPr>
@@ -7626,7 +7770,7 @@
       </p:sp>
       <p:sp>
         <p:nvSpPr>
-          <p:cNvPr id="9" name="Text 7"/>
+          <p:cNvPr id="10" name="Text 7"/>
           <p:cNvSpPr/>
           <p:nvPr/>
         </p:nvSpPr>
@@ -7679,7 +7823,7 @@
       </p:sp>
       <p:sp>
         <p:nvSpPr>
-          <p:cNvPr id="10" name="Text 8"/>
+          <p:cNvPr id="11" name="Text 8"/>
           <p:cNvSpPr/>
           <p:nvPr/>
         </p:nvSpPr>
@@ -7718,7 +7862,7 @@
       </p:sp>
       <p:sp>
         <p:nvSpPr>
-          <p:cNvPr id="11" name="Text 9"/>
+          <p:cNvPr id="12" name="Text 9"/>
           <p:cNvSpPr/>
           <p:nvPr/>
         </p:nvSpPr>
@@ -7771,7 +7915,7 @@
       </p:sp>
       <p:sp>
         <p:nvSpPr>
-          <p:cNvPr id="12" name="Text 10"/>
+          <p:cNvPr id="13" name="Text 10"/>
           <p:cNvSpPr/>
           <p:nvPr/>
         </p:nvSpPr>
@@ -7810,7 +7954,7 @@
       </p:sp>
       <p:sp>
         <p:nvSpPr>
-          <p:cNvPr id="13" name="Text 11"/>
+          <p:cNvPr id="14" name="Text 11"/>
           <p:cNvSpPr/>
           <p:nvPr/>
         </p:nvSpPr>
@@ -7863,7 +8007,7 @@
       </p:sp>
       <p:sp>
         <p:nvSpPr>
-          <p:cNvPr id="14" name="Text 12"/>
+          <p:cNvPr id="15" name="Text 12"/>
           <p:cNvSpPr/>
           <p:nvPr/>
         </p:nvSpPr>
@@ -7902,7 +8046,7 @@
       </p:sp>
       <p:sp>
         <p:nvSpPr>
-          <p:cNvPr id="15" name="Text 13"/>
+          <p:cNvPr id="16" name="Text 13"/>
           <p:cNvSpPr/>
           <p:nvPr/>
         </p:nvSpPr>
@@ -7955,7 +8099,7 @@
       </p:sp>
       <p:sp>
         <p:nvSpPr>
-          <p:cNvPr id="16" name="Text 14"/>
+          <p:cNvPr id="17" name="Text 14"/>
           <p:cNvSpPr/>
           <p:nvPr/>
         </p:nvSpPr>
@@ -7994,7 +8138,7 @@
       </p:sp>
       <p:sp>
         <p:nvSpPr>
-          <p:cNvPr id="17" name="Text 15"/>
+          <p:cNvPr id="18" name="Text 15"/>
           <p:cNvSpPr/>
           <p:nvPr/>
         </p:nvSpPr>
@@ -8047,7 +8191,7 @@
       </p:sp>
       <p:sp>
         <p:nvSpPr>
-          <p:cNvPr id="18" name="Shape 16"/>
+          <p:cNvPr id="19" name="Shape 16"/>
           <p:cNvSpPr/>
           <p:nvPr/>
         </p:nvSpPr>
@@ -8070,7 +8214,7 @@
       </p:sp>
       <p:sp>
         <p:nvSpPr>
-          <p:cNvPr id="19" name="Text 17"/>
+          <p:cNvPr id="20" name="Text 17"/>
           <p:cNvSpPr/>
           <p:nvPr/>
         </p:nvSpPr>

</xml_diff>